<commit_message>
batch: 260/563 gemeenten (tussentijds)
</commit_message>
<xml_diff>
--- a/Fluctus_Laadplan_Landen.pptx
+++ b/Fluctus_Laadplan_Landen.pptx
@@ -118,7 +118,7 @@
 </p:presentation>
 </file>
 
-<file path=ppt/charts/chart2.xml><?xml version="1.0" encoding="utf-8"?>
+<file path=ppt/charts/chart245.xml><?xml version="1.0" encoding="utf-8"?>
 <c:chartSpace xmlns:c="http://schemas.openxmlformats.org/drawingml/2006/chart" xmlns:a="http://schemas.openxmlformats.org/drawingml/2006/main" xmlns:r="http://schemas.openxmlformats.org/officeDocument/2006/relationships">
   <c:date1904 val="0"/>
   <c:roundedCorners val="1"/>
@@ -10846,7 +10846,7 @@
                 <a:ea typeface="Arial" pitchFamily="34" charset="-122"/>
                 <a:cs typeface="Arial" pitchFamily="34" charset="-120"/>
               </a:rPr>
-              <a:t>* Loadfactor t.o.v. referentiestation: kopstation HANNU150 (150 kV), 8.8 km van Landen (laagste load van de cluster &lt;5 km). · v6</a:t>
+              <a:t>* Loadfactor t.o.v. referentiestation: kopstation HANNU150 (150 kV), 9.2 km van Landen (laagste load van de cluster &lt;5 km). · v6</a:t>
             </a:r>
             <a:endParaRPr lang="en-US" sz="900" dirty="0"/>
           </a:p>
@@ -10991,7 +10991,7 @@
                 <a:ea typeface="Arial" pitchFamily="34" charset="-122"/>
                 <a:cs typeface="Arial" pitchFamily="34" charset="-120"/>
               </a:rPr>
-              <a:t>Loadfactor van station HANNU150 (150 kV) — dichtste kopstation bij Landen, op ± 8.8 km (laagste load van de cluster &lt;5 km). Flex ≈ 13.5 MW (11 kW/wagen + 10 kW batterij) op 175 MW firm capacity.</a:t>
+              <a:t>Loadfactor van station HANNU150 (150 kV) — dichtste kopstation bij Landen, op ± 9.2 km (laagste load van de cluster &lt;5 km). Flex ≈ 13.5 MW (11 kW/wagen + 10 kW batterij) op 175 MW firm capacity.</a:t>
             </a:r>
             <a:endParaRPr lang="en-US" sz="900" dirty="0"/>
           </a:p>

</xml_diff>